<commit_message>
fix public url in pptx
</commit_message>
<xml_diff>
--- a/PhoBuddy_Presentation.pptx
+++ b/PhoBuddy_Presentation.pptx
@@ -15507,41 +15507,66 @@
           <a:lstStyle/>
           <a:p>
             <a:r>
+              <a:rPr sz="1100" dirty="0">
+                <a:solidFill>
+                  <a:srgbClr val="FFFFFF"/>
+                </a:solidFill>
+              </a:rPr>
+              <a:t>🌐  Deployed: </a:t>
+            </a:r>
+            <a:r>
+              <a:rPr lang="en-GB" sz="1100" dirty="0">
+                <a:solidFill>
+                  <a:srgbClr val="FFFFFF"/>
+                </a:solidFill>
+                <a:hlinkClick r:id="rId3"/>
+              </a:rPr>
+              <a:t>https://asian-cooking-bot.streamlit.app</a:t>
+            </a:r>
+            <a:r>
+              <a:rPr lang="en-GB" sz="1100">
+                <a:solidFill>
+                  <a:srgbClr val="FFFFFF"/>
+                </a:solidFill>
+                <a:hlinkClick r:id="rId3"/>
+              </a:rPr>
+              <a:t>/</a:t>
+            </a:r>
+            <a:r>
+              <a:rPr lang="en-GB" sz="1100">
+                <a:solidFill>
+                  <a:srgbClr val="FFFFFF"/>
+                </a:solidFill>
+              </a:rPr>
+              <a:t> </a:t>
+            </a:r>
+            <a:r>
               <a:rPr sz="1100">
                 <a:solidFill>
                   <a:srgbClr val="FFFFFF"/>
                 </a:solidFill>
               </a:rPr>
-              <a:t>🌐  Deployed: </a:t>
-            </a:r>
-            <a:r>
-              <a:rPr sz="1100">
+              <a:t>|  </a:t>
+            </a:r>
+            <a:r>
+              <a:rPr sz="1100" dirty="0">
                 <a:solidFill>
                   <a:srgbClr val="FFFFFF"/>
                 </a:solidFill>
-                <a:hlinkClick r:id="rId3"/>
-              </a:rPr>
-              <a:t>https://asian-cooking-bot-cpkc3vyb9bkw8ktdtdxhvn.streamlit.app/</a:t>
-            </a:r>
-            <a:r>
-              <a:rPr sz="1100">
+              </a:rPr>
+              <a:t>GitHub: </a:t>
+            </a:r>
+            <a:r>
+              <a:rPr sz="1100" dirty="0">
                 <a:solidFill>
                   <a:srgbClr val="FFFFFF"/>
                 </a:solidFill>
-              </a:rPr>
-              <a:t> |  GitHub: </a:t>
-            </a:r>
-            <a:r>
-              <a:rPr sz="1100">
-                <a:solidFill>
-                  <a:srgbClr val="FFFFFF"/>
-                </a:solidFill>
                 <a:hlinkClick r:id="rId4"/>
               </a:rPr>
               <a:t>https://github.com/asaah262/asian-cooking-bot</a:t>
             </a:r>
             <a:r>
-              <a:rPr sz="1100">
+              <a:rPr sz="1100" dirty="0">
                 <a:solidFill>
                   <a:srgbClr val="FFFFFF"/>
                 </a:solidFill>

</xml_diff>

<commit_message>
add VideoIngestionDemo.m4v and final cleanup
</commit_message>
<xml_diff>
--- a/PhoBuddy_Presentation.pptx
+++ b/PhoBuddy_Presentation.pptx
@@ -3122,7 +3122,7 @@
               <a:buNone/>
             </a:pPr>
             <a:r>
-              <a:rPr sz="1400" b="1">
+              <a:rPr sz="1400" b="1" dirty="0">
                 <a:solidFill>
                   <a:srgbClr val="1A1A2E"/>
                 </a:solidFill>
@@ -9773,12 +9773,20 @@
               <a:buNone/>
             </a:pPr>
             <a:r>
-              <a:rPr sz="1000">
+              <a:rPr sz="1000" dirty="0" err="1">
                 <a:solidFill>
                   <a:srgbClr val="F5A623"/>
                 </a:solidFill>
               </a:rPr>
-              <a:t>Groundedness Score</a:t>
+              <a:t>Groundedness</a:t>
+            </a:r>
+            <a:r>
+              <a:rPr sz="1000" dirty="0">
+                <a:solidFill>
+                  <a:srgbClr val="F5A623"/>
+                </a:solidFill>
+              </a:rPr>
+              <a:t> Score</a:t>
             </a:r>
           </a:p>
         </p:txBody>
@@ -11729,7 +11737,7 @@
               </a:defRPr>
             </a:pPr>
             <a:r>
-              <a:rPr sz="825" b="0">
+              <a:rPr lang="en-US" sz="825" b="0" dirty="0">
                 <a:solidFill>
                   <a:srgbClr val="FBBF24"/>
                 </a:solidFill>
@@ -11737,7 +11745,18 @@
                 <a:ea typeface="Arial"/>
                 <a:cs typeface="Arial"/>
               </a:rPr>
-              <a:t>Groundedness Score</a:t>
+              <a:t>Hallucination</a:t>
+            </a:r>
+            <a:r>
+              <a:rPr sz="825" b="0" dirty="0">
+                <a:solidFill>
+                  <a:srgbClr val="FBBF24"/>
+                </a:solidFill>
+                <a:latin typeface="Arial"/>
+                <a:ea typeface="Arial"/>
+                <a:cs typeface="Arial"/>
+              </a:rPr>
+              <a:t> Score</a:t>
             </a:r>
           </a:p>
         </p:txBody>
@@ -12656,6 +12675,7 @@
           <a:bodyPr/>
           <a:lstStyle/>
           <a:p>
+            <a:pPr marL="0" indent="0" algn="l" defTabSz="914400" rtl="0"/>
             <a:endParaRPr lang="en-DE"/>
           </a:p>
         </p:txBody>
@@ -13802,6 +13822,7 @@
           <a:bodyPr/>
           <a:lstStyle/>
           <a:p>
+            <a:pPr marL="0" indent="0" algn="l" defTabSz="914400" rtl="0"/>
             <a:endParaRPr lang="en-DE"/>
           </a:p>
         </p:txBody>

</xml_diff>